<commit_message>
docs: corrige grupo (68) e RM no pitch
</commit_message>
<xml_diff>
--- a/docs/EcoTracker_Pitch.pptx
+++ b/docs/EcoTracker_Pitch.pptx
@@ -3265,7 +3265,7 @@
                 </a:solidFill>
                 <a:latin typeface="Calibri"/>
               </a:rPr>
-              <a:t>Startup One  |  FIAP  |  Grupo 106</a:t>
+              <a:t>Startup One  |  FIAP  |  Grupo 68</a:t>
             </a:r>
           </a:p>
         </p:txBody>
@@ -3279,7 +3279,7 @@
         <p:spPr>
           <a:xfrm>
             <a:off x="900000" y="5256000"/>
-            <a:ext cx="8640000" cy="360000"/>
+            <a:ext cx="9360000" cy="360000"/>
           </a:xfrm>
           <a:prstGeom prst="rect">
             <a:avLst/>
@@ -3307,7 +3307,7 @@
                 </a:solidFill>
                 <a:latin typeface="Calibri"/>
               </a:rPr>
-              <a:t>Markus de Figueiredo Ferraz Wirz  –  markusfwirz@gmail.com</a:t>
+              <a:t>Markus de Figueiredo Ferraz Wirz  –  RM561367  –  markusfwirz@gmail.com</a:t>
             </a:r>
           </a:p>
         </p:txBody>
@@ -5215,7 +5215,7 @@
                 </a:solidFill>
                 <a:latin typeface="Calibri"/>
               </a:rPr>
-              <a:t>Fundador – produto e engenharia</a:t>
+              <a:t>Fundador – produto e engenharia  |  RM561367</a:t>
             </a:r>
           </a:p>
         </p:txBody>
@@ -5314,7 +5314,7 @@
                 </a:solidFill>
                 <a:latin typeface="Calibri"/>
               </a:rPr>
-              <a:t>●  FIAP – Análise e Desenvolvimento de Sistemas, Grupo 106</a:t>
+              <a:t>●  FIAP – Análise e Desenvolvimento de Sistemas, Grupo 68</a:t>
             </a:r>
           </a:p>
         </p:txBody>
@@ -5727,7 +5727,7 @@
                 </a:solidFill>
                 <a:latin typeface="Calibri"/>
               </a:rPr>
-              <a:t>Markus de Figueiredo Ferraz Wirz  –  markusfwirz@gmail.com  –  FIAP, Grupo 106</a:t>
+              <a:t>Markus de Figueiredo Ferraz Wirz (RM561367)  –  markusfwirz@gmail.com  –  FIAP, Grupo 68</a:t>
             </a:r>
           </a:p>
         </p:txBody>

</xml_diff>